<commit_message>
Update week38 supervisor meeting notes
Co-Authored-By: Claude Sonnet 5 <noreply@anthropic.com>
</commit_message>
<xml_diff>
--- a/supervisor-meetings/week38-supervisor-meeting-notes.pptx
+++ b/supervisor-meetings/week38-supervisor-meeting-notes.pptx
@@ -4,12 +4,14 @@
   <p:sldMasterIdLst>
     <p:sldMasterId id="2147483648" r:id="rId1"/>
   </p:sldMasterIdLst>
+  <p:notesMasterIdLst>
+    <p:notesMasterId r:id="rId4"/>
+  </p:notesMasterIdLst>
   <p:sldIdLst>
-    <p:sldId id="256" r:id="rId7"/>
-    <p:sldId id="257" r:id="rId9"/>
-    <p:sldId id="258" r:id="rId10"/>
+    <p:sldId id="256" r:id="rId2"/>
+    <p:sldId id="257" r:id="rId3"/>
   </p:sldIdLst>
-  <p:sldSz cx="12191695" cy="6858000" type="screen4x3"/>
+  <p:sldSz cx="12192000" cy="6858000"/>
   <p:notesSz cx="6858000" cy="9144000"/>
   <p:defaultTextStyle>
     <a:defPPr>
@@ -106,11 +108,27 @@
       </a:defRPr>
     </a:lvl9pPr>
   </p:defaultTextStyle>
+  <p:extLst>
+    <p:ext uri="{EFAFB233-063F-42B5-8137-9DF3F51BA10A}">
+      <p15:sldGuideLst xmlns:p15="http://schemas.microsoft.com/office/powerpoint/2012/main">
+        <p15:guide id="1" orient="horz" pos="2160">
+          <p15:clr>
+            <a:srgbClr val="A4A3A4"/>
+          </p15:clr>
+        </p15:guide>
+        <p15:guide id="2" pos="2880">
+          <p15:clr>
+            <a:srgbClr val="A4A3A4"/>
+          </p15:clr>
+        </p15:guide>
+      </p15:sldGuideLst>
+    </p:ext>
+  </p:extLst>
 </p:presentation>
 </file>
 
 <file path=ppt/notesMasters/notesMaster1.xml><?xml version="1.0" encoding="utf-8"?>
-<p:notesMaster xmlns:a="http://schemas.openxmlformats.org/drawingml/2006/main" xmlns:p="http://schemas.openxmlformats.org/presentationml/2006/main" xmlns:r="http://schemas.openxmlformats.org/officeDocument/2006/relationships">
+<p:notesMaster xmlns:a="http://schemas.openxmlformats.org/drawingml/2006/main" xmlns:r="http://schemas.openxmlformats.org/officeDocument/2006/relationships" xmlns:p="http://schemas.openxmlformats.org/presentationml/2006/main">
   <p:cSld>
     <p:bg>
       <p:bgRef idx="1001">
@@ -131,241 +149,16 @@
           <a:chExt cx="0" cy="0"/>
         </a:xfrm>
       </p:grpSpPr>
-      <p:sp>
-        <p:nvSpPr>
-          <p:cNvPr id="2" name="Header Placeholder 1"/>
-          <p:cNvSpPr>
-            <a:spLocks noGrp="1"/>
-          </p:cNvSpPr>
-          <p:nvPr>
-            <p:ph type="hdr" sz="quarter"/>
-          </p:nvPr>
-        </p:nvSpPr>
-        <p:spPr>
-          <a:xfrm>
-            <a:off x="0" y="0"/>
-            <a:ext cx="2971800" cy="457200"/>
-          </a:xfrm>
-          <a:prstGeom prst="rect">
-            <a:avLst/>
-          </a:prstGeom>
-        </p:spPr>
-        <p:txBody>
-          <a:bodyPr vert="horz" lIns="91440" tIns="45720" rIns="91440" bIns="45720" rtlCol="0"/>
-          <a:lstStyle>
-            <a:lvl1pPr algn="l">
-              <a:defRPr sz="1200"/>
-            </a:lvl1pPr>
-          </a:lstStyle>
-          <a:p>
-            <a:endParaRPr lang="en-US"/>
-          </a:p>
-        </p:txBody>
-      </p:sp>
-      <p:sp>
-        <p:nvSpPr>
-          <p:cNvPr id="3" name="Date Placeholder 2"/>
-          <p:cNvSpPr>
-            <a:spLocks noGrp="1"/>
-          </p:cNvSpPr>
-          <p:nvPr>
-            <p:ph type="dt" idx="1"/>
-          </p:nvPr>
-        </p:nvSpPr>
-        <p:spPr>
-          <a:xfrm>
-            <a:off x="3884613" y="0"/>
-            <a:ext cx="2971800" cy="457200"/>
-          </a:xfrm>
-          <a:prstGeom prst="rect">
-            <a:avLst/>
-          </a:prstGeom>
-        </p:spPr>
-        <p:txBody>
-          <a:bodyPr vert="horz" lIns="91440" tIns="45720" rIns="91440" bIns="45720" rtlCol="0"/>
-          <a:lstStyle>
-            <a:lvl1pPr algn="r">
-              <a:defRPr sz="1200"/>
-            </a:lvl1pPr>
-          </a:lstStyle>
-          <a:p>
-            <a:fld id="{0F89C1C7-3DCD-1040-A9CF-14679D8B5DDD}" type="datetimeFigureOut">
-              <a:rPr lang="en-US" smtClean="0"/>
-              <a:t>10/17/16</a:t>
-            </a:fld>
-            <a:endParaRPr lang="en-US"/>
-          </a:p>
-        </p:txBody>
-      </p:sp>
-      <p:sp>
-        <p:nvSpPr>
-          <p:cNvPr id="4" name="Slide Image Placeholder 3"/>
-          <p:cNvSpPr>
-            <a:spLocks noGrp="1" noRot="1" noChangeAspect="1"/>
-          </p:cNvSpPr>
-          <p:nvPr>
-            <p:ph type="sldImg" idx="2"/>
-          </p:nvPr>
-        </p:nvSpPr>
-        <p:spPr>
-          <a:xfrm>
-            <a:off x="1143000" y="685800"/>
-            <a:ext cx="4572000" cy="3429000"/>
-          </a:xfrm>
-          <a:prstGeom prst="rect">
-            <a:avLst/>
-          </a:prstGeom>
-          <a:noFill/>
-          <a:ln w="12700">
-            <a:solidFill>
-              <a:prstClr val="black"/>
-            </a:solidFill>
-          </a:ln>
-        </p:spPr>
-        <p:txBody>
-          <a:bodyPr vert="horz" lIns="91440" tIns="45720" rIns="91440" bIns="45720" rtlCol="0" anchor="ctr"/>
-          <a:lstStyle/>
-          <a:p>
-            <a:endParaRPr lang="en-US"/>
-          </a:p>
-        </p:txBody>
-      </p:sp>
-      <p:sp>
-        <p:nvSpPr>
-          <p:cNvPr id="5" name="Notes Placeholder 4"/>
-          <p:cNvSpPr>
-            <a:spLocks noGrp="1"/>
-          </p:cNvSpPr>
-          <p:nvPr>
-            <p:ph type="body" sz="quarter" idx="3"/>
-          </p:nvPr>
-        </p:nvSpPr>
-        <p:spPr>
-          <a:xfrm>
-            <a:off x="685800" y="4343400"/>
-            <a:ext cx="5486400" cy="4114800"/>
-          </a:xfrm>
-          <a:prstGeom prst="rect">
-            <a:avLst/>
-          </a:prstGeom>
-        </p:spPr>
-        <p:txBody>
-          <a:bodyPr vert="horz" lIns="91440" tIns="45720" rIns="91440" bIns="45720" rtlCol="0"/>
-          <a:lstStyle/>
-          <a:p>
-            <a:pPr lvl="0"/>
-            <a:r>
-              <a:rPr lang="en-US" smtClean="0"/>
-              <a:t>Click to edit Master text styles</a:t>
-            </a:r>
-          </a:p>
-          <a:p>
-            <a:pPr lvl="1"/>
-            <a:r>
-              <a:rPr lang="en-US" smtClean="0"/>
-              <a:t>Second level</a:t>
-            </a:r>
-          </a:p>
-          <a:p>
-            <a:pPr lvl="2"/>
-            <a:r>
-              <a:rPr lang="en-US" smtClean="0"/>
-              <a:t>Third level</a:t>
-            </a:r>
-          </a:p>
-          <a:p>
-            <a:pPr lvl="3"/>
-            <a:r>
-              <a:rPr lang="en-US" smtClean="0"/>
-              <a:t>Fourth level</a:t>
-            </a:r>
-          </a:p>
-          <a:p>
-            <a:pPr lvl="4"/>
-            <a:r>
-              <a:rPr lang="en-US" smtClean="0"/>
-              <a:t>Fifth level</a:t>
-            </a:r>
-            <a:endParaRPr lang="en-US"/>
-          </a:p>
-        </p:txBody>
-      </p:sp>
-      <p:sp>
-        <p:nvSpPr>
-          <p:cNvPr id="6" name="Footer Placeholder 5"/>
-          <p:cNvSpPr>
-            <a:spLocks noGrp="1"/>
-          </p:cNvSpPr>
-          <p:nvPr>
-            <p:ph type="ftr" sz="quarter" idx="4"/>
-          </p:nvPr>
-        </p:nvSpPr>
-        <p:spPr>
-          <a:xfrm>
-            <a:off x="0" y="8685213"/>
-            <a:ext cx="2971800" cy="457200"/>
-          </a:xfrm>
-          <a:prstGeom prst="rect">
-            <a:avLst/>
-          </a:prstGeom>
-        </p:spPr>
-        <p:txBody>
-          <a:bodyPr vert="horz" lIns="91440" tIns="45720" rIns="91440" bIns="45720" rtlCol="0" anchor="b"/>
-          <a:lstStyle>
-            <a:lvl1pPr algn="l">
-              <a:defRPr sz="1200"/>
-            </a:lvl1pPr>
-          </a:lstStyle>
-          <a:p>
-            <a:endParaRPr lang="en-US"/>
-          </a:p>
-        </p:txBody>
-      </p:sp>
-      <p:sp>
-        <p:nvSpPr>
-          <p:cNvPr id="7" name="Slide Number Placeholder 6"/>
-          <p:cNvSpPr>
-            <a:spLocks noGrp="1"/>
-          </p:cNvSpPr>
-          <p:nvPr>
-            <p:ph type="sldNum" sz="quarter" idx="5"/>
-          </p:nvPr>
-        </p:nvSpPr>
-        <p:spPr>
-          <a:xfrm>
-            <a:off x="3884613" y="8685213"/>
-            <a:ext cx="2971800" cy="457200"/>
-          </a:xfrm>
-          <a:prstGeom prst="rect">
-            <a:avLst/>
-          </a:prstGeom>
-        </p:spPr>
-        <p:txBody>
-          <a:bodyPr vert="horz" lIns="91440" tIns="45720" rIns="91440" bIns="45720" rtlCol="0" anchor="b"/>
-          <a:lstStyle>
-            <a:lvl1pPr algn="r">
-              <a:defRPr sz="1200"/>
-            </a:lvl1pPr>
-          </a:lstStyle>
-          <a:p>
-            <a:fld id="{BB5E49A5-4136-284D-997B-48E1D791AD67}" type="slidenum">
-              <a:rPr lang="en-US" smtClean="0"/>
-              <a:t>‹#›</a:t>
-            </a:fld>
-            <a:endParaRPr lang="en-US"/>
-          </a:p>
-        </p:txBody>
-      </p:sp>
     </p:spTree>
     <p:extLst>
       <p:ext uri="{BB962C8B-B14F-4D97-AF65-F5344CB8AC3E}">
-        <p14:creationId xmlns:p14="http://schemas.microsoft.com/office/powerpoint/2010/main" val="2623252185"/>
+        <p14:creationId xmlns:p14="http://schemas.microsoft.com/office/powerpoint/2010/main" val="3088151693"/>
       </p:ext>
     </p:extLst>
   </p:cSld>
   <p:clrMap bg1="lt1" tx1="dk1" bg2="lt2" tx2="dk2" accent1="accent1" accent2="accent2" accent3="accent3" accent4="accent4" accent5="accent5" accent6="accent6" hlink="hlink" folHlink="folHlink"/>
   <p:notesStyle>
-    <a:lvl1pPr marL="0" algn="l" defTabSz="457200" rtl="0" eaLnBrk="1" latinLnBrk="0" hangingPunct="1">
+    <a:lvl1pPr marL="0" algn="l" defTabSz="914400" rtl="0" eaLnBrk="1" latinLnBrk="0" hangingPunct="1">
       <a:defRPr sz="1200" kern="1200">
         <a:solidFill>
           <a:schemeClr val="tx1"/>
@@ -375,7 +168,7 @@
         <a:cs typeface="+mn-cs"/>
       </a:defRPr>
     </a:lvl1pPr>
-    <a:lvl2pPr marL="457200" algn="l" defTabSz="457200" rtl="0" eaLnBrk="1" latinLnBrk="0" hangingPunct="1">
+    <a:lvl2pPr marL="457200" algn="l" defTabSz="914400" rtl="0" eaLnBrk="1" latinLnBrk="0" hangingPunct="1">
       <a:defRPr sz="1200" kern="1200">
         <a:solidFill>
           <a:schemeClr val="tx1"/>
@@ -385,7 +178,7 @@
         <a:cs typeface="+mn-cs"/>
       </a:defRPr>
     </a:lvl2pPr>
-    <a:lvl3pPr marL="914400" algn="l" defTabSz="457200" rtl="0" eaLnBrk="1" latinLnBrk="0" hangingPunct="1">
+    <a:lvl3pPr marL="914400" algn="l" defTabSz="914400" rtl="0" eaLnBrk="1" latinLnBrk="0" hangingPunct="1">
       <a:defRPr sz="1200" kern="1200">
         <a:solidFill>
           <a:schemeClr val="tx1"/>
@@ -395,7 +188,7 @@
         <a:cs typeface="+mn-cs"/>
       </a:defRPr>
     </a:lvl3pPr>
-    <a:lvl4pPr marL="1371600" algn="l" defTabSz="457200" rtl="0" eaLnBrk="1" latinLnBrk="0" hangingPunct="1">
+    <a:lvl4pPr marL="1371600" algn="l" defTabSz="914400" rtl="0" eaLnBrk="1" latinLnBrk="0" hangingPunct="1">
       <a:defRPr sz="1200" kern="1200">
         <a:solidFill>
           <a:schemeClr val="tx1"/>
@@ -405,7 +198,7 @@
         <a:cs typeface="+mn-cs"/>
       </a:defRPr>
     </a:lvl4pPr>
-    <a:lvl5pPr marL="1828800" algn="l" defTabSz="457200" rtl="0" eaLnBrk="1" latinLnBrk="0" hangingPunct="1">
+    <a:lvl5pPr marL="1828800" algn="l" defTabSz="914400" rtl="0" eaLnBrk="1" latinLnBrk="0" hangingPunct="1">
       <a:defRPr sz="1200" kern="1200">
         <a:solidFill>
           <a:schemeClr val="tx1"/>
@@ -415,7 +208,7 @@
         <a:cs typeface="+mn-cs"/>
       </a:defRPr>
     </a:lvl5pPr>
-    <a:lvl6pPr marL="2286000" algn="l" defTabSz="457200" rtl="0" eaLnBrk="1" latinLnBrk="0" hangingPunct="1">
+    <a:lvl6pPr marL="2286000" algn="l" defTabSz="914400" rtl="0" eaLnBrk="1" latinLnBrk="0" hangingPunct="1">
       <a:defRPr sz="1200" kern="1200">
         <a:solidFill>
           <a:schemeClr val="tx1"/>
@@ -425,7 +218,7 @@
         <a:cs typeface="+mn-cs"/>
       </a:defRPr>
     </a:lvl6pPr>
-    <a:lvl7pPr marL="2743200" algn="l" defTabSz="457200" rtl="0" eaLnBrk="1" latinLnBrk="0" hangingPunct="1">
+    <a:lvl7pPr marL="2743200" algn="l" defTabSz="914400" rtl="0" eaLnBrk="1" latinLnBrk="0" hangingPunct="1">
       <a:defRPr sz="1200" kern="1200">
         <a:solidFill>
           <a:schemeClr val="tx1"/>
@@ -435,7 +228,7 @@
         <a:cs typeface="+mn-cs"/>
       </a:defRPr>
     </a:lvl7pPr>
-    <a:lvl8pPr marL="3200400" algn="l" defTabSz="457200" rtl="0" eaLnBrk="1" latinLnBrk="0" hangingPunct="1">
+    <a:lvl8pPr marL="3200400" algn="l" defTabSz="914400" rtl="0" eaLnBrk="1" latinLnBrk="0" hangingPunct="1">
       <a:defRPr sz="1200" kern="1200">
         <a:solidFill>
           <a:schemeClr val="tx1"/>
@@ -445,7 +238,7 @@
         <a:cs typeface="+mn-cs"/>
       </a:defRPr>
     </a:lvl8pPr>
-    <a:lvl9pPr marL="3657600" algn="l" defTabSz="457200" rtl="0" eaLnBrk="1" latinLnBrk="0" hangingPunct="1">
+    <a:lvl9pPr marL="3657600" algn="l" defTabSz="914400" rtl="0" eaLnBrk="1" latinLnBrk="0" hangingPunct="1">
       <a:defRPr sz="1200" kern="1200">
         <a:solidFill>
           <a:schemeClr val="tx1"/>
@@ -460,7 +253,7 @@
 </file>
 
 <file path=ppt/notesSlides/notesSlide1.xml><?xml version="1.0" encoding="utf-8"?>
-<p:notes xmlns:a="http://schemas.openxmlformats.org/drawingml/2006/main" xmlns:p="http://schemas.openxmlformats.org/presentationml/2006/main" xmlns:r="http://schemas.openxmlformats.org/officeDocument/2006/relationships">
+<p:notes xmlns:a="http://schemas.openxmlformats.org/drawingml/2006/main" xmlns:r="http://schemas.openxmlformats.org/officeDocument/2006/relationships" xmlns:p="http://schemas.openxmlformats.org/presentationml/2006/main">
   <p:cSld>
     <p:spTree>
       <p:nvGrpSpPr>
@@ -480,7 +273,7 @@
         <p:nvSpPr>
           <p:cNvPr id="2" name="Slide Image Placeholder 1"/>
           <p:cNvSpPr>
-            <a:spLocks noGrp="1"/>
+            <a:spLocks noGrp="1" noRot="1" noChangeAspect="1"/>
           </p:cNvSpPr>
           <p:nvPr>
             <p:ph type="sldImg" idx="2"/>
@@ -495,7 +288,7 @@
             <a:spLocks noGrp="1"/>
           </p:cNvSpPr>
           <p:nvPr>
-            <p:ph type="body" idx="3" sz="quarter"/>
+            <p:ph type="body" sz="quarter" idx="3"/>
           </p:nvPr>
         </p:nvSpPr>
         <p:spPr/>
@@ -516,7 +309,7 @@
             <a:spLocks noGrp="1"/>
           </p:cNvSpPr>
           <p:nvPr>
-            <p:ph type="sldNum" idx="5" sz="quarter"/>
+            <p:ph type="sldNum" sz="quarter" idx="5"/>
           </p:nvPr>
         </p:nvSpPr>
         <p:spPr/>
@@ -530,7 +323,7 @@
 </file>
 
 <file path=ppt/notesSlides/notesSlide2.xml><?xml version="1.0" encoding="utf-8"?>
-<p:notes xmlns:a="http://schemas.openxmlformats.org/drawingml/2006/main" xmlns:p="http://schemas.openxmlformats.org/presentationml/2006/main" xmlns:r="http://schemas.openxmlformats.org/officeDocument/2006/relationships">
+<p:notes xmlns:a="http://schemas.openxmlformats.org/drawingml/2006/main" xmlns:r="http://schemas.openxmlformats.org/officeDocument/2006/relationships" xmlns:p="http://schemas.openxmlformats.org/presentationml/2006/main">
   <p:cSld>
     <p:spTree>
       <p:nvGrpSpPr>
@@ -550,7 +343,7 @@
         <p:nvSpPr>
           <p:cNvPr id="2" name="Slide Image Placeholder 1"/>
           <p:cNvSpPr>
-            <a:spLocks noGrp="1"/>
+            <a:spLocks noGrp="1" noRot="1" noChangeAspect="1"/>
           </p:cNvSpPr>
           <p:nvPr>
             <p:ph type="sldImg" idx="2"/>
@@ -565,7 +358,7 @@
             <a:spLocks noGrp="1"/>
           </p:cNvSpPr>
           <p:nvPr>
-            <p:ph type="body" idx="3" sz="quarter"/>
+            <p:ph type="body" sz="quarter" idx="3"/>
           </p:nvPr>
         </p:nvSpPr>
         <p:spPr/>
@@ -586,77 +379,7 @@
             <a:spLocks noGrp="1"/>
           </p:cNvSpPr>
           <p:nvPr>
-            <p:ph type="sldNum" idx="5" sz="quarter"/>
-          </p:nvPr>
-        </p:nvSpPr>
-        <p:spPr/>
-      </p:sp>
-    </p:spTree>
-  </p:cSld>
-  <p:clrMapOvr>
-    <a:masterClrMapping/>
-  </p:clrMapOvr>
-</p:notes>
-</file>
-
-<file path=ppt/notesSlides/notesSlide3.xml><?xml version="1.0" encoding="utf-8"?>
-<p:notes xmlns:a="http://schemas.openxmlformats.org/drawingml/2006/main" xmlns:p="http://schemas.openxmlformats.org/presentationml/2006/main" xmlns:r="http://schemas.openxmlformats.org/officeDocument/2006/relationships">
-  <p:cSld>
-    <p:spTree>
-      <p:nvGrpSpPr>
-        <p:cNvPr id="1" name=""/>
-        <p:cNvGrpSpPr/>
-        <p:nvPr/>
-      </p:nvGrpSpPr>
-      <p:grpSpPr>
-        <a:xfrm>
-          <a:off x="0" y="0"/>
-          <a:ext cx="0" cy="0"/>
-          <a:chOff x="0" y="0"/>
-          <a:chExt cx="0" cy="0"/>
-        </a:xfrm>
-      </p:grpSpPr>
-      <p:sp>
-        <p:nvSpPr>
-          <p:cNvPr id="2" name="Slide Image Placeholder 1"/>
-          <p:cNvSpPr>
-            <a:spLocks noGrp="1"/>
-          </p:cNvSpPr>
-          <p:nvPr>
-            <p:ph type="sldImg" idx="2"/>
-          </p:nvPr>
-        </p:nvSpPr>
-        <p:spPr/>
-      </p:sp>
-      <p:sp>
-        <p:nvSpPr>
-          <p:cNvPr id="3" name="Notes Placeholder 2"/>
-          <p:cNvSpPr>
-            <a:spLocks noGrp="1"/>
-          </p:cNvSpPr>
-          <p:nvPr>
-            <p:ph type="body" idx="3" sz="quarter"/>
-          </p:nvPr>
-        </p:nvSpPr>
-        <p:spPr/>
-        <p:txBody>
-          <a:bodyPr/>
-          <a:lstStyle/>
-          <a:p>
-            <a:r>
-              <a:t>Push hardest on 1 and 2. Several things we've written down depend on the four-kinds reading being right. Question 2 matters most for the thesis — the whole premise rests on what that expert burden actually consists of.</a:t>
-            </a:r>
-          </a:p>
-        </p:txBody>
-      </p:sp>
-      <p:sp>
-        <p:nvSpPr>
-          <p:cNvPr id="4" name="Slide Number Placeholder 3"/>
-          <p:cNvSpPr>
-            <a:spLocks noGrp="1"/>
-          </p:cNvSpPr>
-          <p:nvPr>
-            <p:ph type="sldNum" idx="5" sz="quarter"/>
+            <p:ph type="sldNum" sz="quarter" idx="5"/>
           </p:nvPr>
         </p:nvSpPr>
         <p:spPr/>
@@ -707,10 +430,9 @@
           <a:lstStyle/>
           <a:p>
             <a:r>
-              <a:rPr lang="en-US" smtClean="0"/>
+              <a:rPr lang="en-US"/>
               <a:t>Click to edit Master title style</a:t>
             </a:r>
-            <a:endParaRPr lang="en-US"/>
           </a:p>
         </p:txBody>
       </p:sp>
@@ -826,10 +548,9 @@
           </a:lstStyle>
           <a:p>
             <a:r>
-              <a:rPr lang="en-US" smtClean="0"/>
+              <a:rPr lang="en-US"/>
               <a:t>Click to edit Master subtitle style</a:t>
             </a:r>
-            <a:endParaRPr lang="en-US"/>
           </a:p>
         </p:txBody>
       </p:sp>
@@ -850,7 +571,7 @@
           <a:p>
             <a:fld id="{5BCAD085-E8A6-8845-BD4E-CB4CCA059FC4}" type="datetimeFigureOut">
               <a:rPr lang="en-US" smtClean="0"/>
-              <a:t>1/27/13</a:t>
+              <a:t>9/16/26</a:t>
             </a:fld>
             <a:endParaRPr lang="en-US"/>
           </a:p>
@@ -944,10 +665,9 @@
           <a:lstStyle/>
           <a:p>
             <a:r>
-              <a:rPr lang="en-US" smtClean="0"/>
+              <a:rPr lang="en-US"/>
               <a:t>Click to edit Master title style</a:t>
             </a:r>
-            <a:endParaRPr lang="en-US"/>
           </a:p>
         </p:txBody>
       </p:sp>
@@ -968,38 +688,37 @@
           <a:p>
             <a:pPr lvl="0"/>
             <a:r>
-              <a:rPr lang="en-US" smtClean="0"/>
+              <a:rPr lang="en-US"/>
               <a:t>Click to edit Master text styles</a:t>
             </a:r>
           </a:p>
           <a:p>
             <a:pPr lvl="1"/>
             <a:r>
-              <a:rPr lang="en-US" smtClean="0"/>
+              <a:rPr lang="en-US"/>
               <a:t>Second level</a:t>
             </a:r>
           </a:p>
           <a:p>
             <a:pPr lvl="2"/>
             <a:r>
-              <a:rPr lang="en-US" smtClean="0"/>
+              <a:rPr lang="en-US"/>
               <a:t>Third level</a:t>
             </a:r>
           </a:p>
           <a:p>
             <a:pPr lvl="3"/>
             <a:r>
-              <a:rPr lang="en-US" smtClean="0"/>
+              <a:rPr lang="en-US"/>
               <a:t>Fourth level</a:t>
             </a:r>
           </a:p>
           <a:p>
             <a:pPr lvl="4"/>
             <a:r>
-              <a:rPr lang="en-US" smtClean="0"/>
+              <a:rPr lang="en-US"/>
               <a:t>Fifth level</a:t>
             </a:r>
-            <a:endParaRPr lang="en-US"/>
           </a:p>
         </p:txBody>
       </p:sp>
@@ -1020,7 +739,7 @@
           <a:p>
             <a:fld id="{5BCAD085-E8A6-8845-BD4E-CB4CCA059FC4}" type="datetimeFigureOut">
               <a:rPr lang="en-US" smtClean="0"/>
-              <a:t>1/27/13</a:t>
+              <a:t>9/16/26</a:t>
             </a:fld>
             <a:endParaRPr lang="en-US"/>
           </a:p>
@@ -1119,10 +838,9 @@
           <a:lstStyle/>
           <a:p>
             <a:r>
-              <a:rPr lang="en-US" smtClean="0"/>
+              <a:rPr lang="en-US"/>
               <a:t>Click to edit Master title style</a:t>
             </a:r>
-            <a:endParaRPr lang="en-US"/>
           </a:p>
         </p:txBody>
       </p:sp>
@@ -1148,38 +866,37 @@
           <a:p>
             <a:pPr lvl="0"/>
             <a:r>
-              <a:rPr lang="en-US" smtClean="0"/>
+              <a:rPr lang="en-US"/>
               <a:t>Click to edit Master text styles</a:t>
             </a:r>
           </a:p>
           <a:p>
             <a:pPr lvl="1"/>
             <a:r>
-              <a:rPr lang="en-US" smtClean="0"/>
+              <a:rPr lang="en-US"/>
               <a:t>Second level</a:t>
             </a:r>
           </a:p>
           <a:p>
             <a:pPr lvl="2"/>
             <a:r>
-              <a:rPr lang="en-US" smtClean="0"/>
+              <a:rPr lang="en-US"/>
               <a:t>Third level</a:t>
             </a:r>
           </a:p>
           <a:p>
             <a:pPr lvl="3"/>
             <a:r>
-              <a:rPr lang="en-US" smtClean="0"/>
+              <a:rPr lang="en-US"/>
               <a:t>Fourth level</a:t>
             </a:r>
           </a:p>
           <a:p>
             <a:pPr lvl="4"/>
             <a:r>
-              <a:rPr lang="en-US" smtClean="0"/>
+              <a:rPr lang="en-US"/>
               <a:t>Fifth level</a:t>
             </a:r>
-            <a:endParaRPr lang="en-US"/>
           </a:p>
         </p:txBody>
       </p:sp>
@@ -1200,7 +917,7 @@
           <a:p>
             <a:fld id="{5BCAD085-E8A6-8845-BD4E-CB4CCA059FC4}" type="datetimeFigureOut">
               <a:rPr lang="en-US" smtClean="0"/>
-              <a:t>1/27/13</a:t>
+              <a:t>9/16/26</a:t>
             </a:fld>
             <a:endParaRPr lang="en-US"/>
           </a:p>
@@ -1294,10 +1011,9 @@
           <a:lstStyle/>
           <a:p>
             <a:r>
-              <a:rPr lang="en-US" smtClean="0"/>
+              <a:rPr lang="en-US"/>
               <a:t>Click to edit Master title style</a:t>
             </a:r>
-            <a:endParaRPr lang="en-US"/>
           </a:p>
         </p:txBody>
       </p:sp>
@@ -1318,38 +1034,37 @@
           <a:p>
             <a:pPr lvl="0"/>
             <a:r>
-              <a:rPr lang="en-US" smtClean="0"/>
+              <a:rPr lang="en-US"/>
               <a:t>Click to edit Master text styles</a:t>
             </a:r>
           </a:p>
           <a:p>
             <a:pPr lvl="1"/>
             <a:r>
-              <a:rPr lang="en-US" smtClean="0"/>
+              <a:rPr lang="en-US"/>
               <a:t>Second level</a:t>
             </a:r>
           </a:p>
           <a:p>
             <a:pPr lvl="2"/>
             <a:r>
-              <a:rPr lang="en-US" smtClean="0"/>
+              <a:rPr lang="en-US"/>
               <a:t>Third level</a:t>
             </a:r>
           </a:p>
           <a:p>
             <a:pPr lvl="3"/>
             <a:r>
-              <a:rPr lang="en-US" smtClean="0"/>
+              <a:rPr lang="en-US"/>
               <a:t>Fourth level</a:t>
             </a:r>
           </a:p>
           <a:p>
             <a:pPr lvl="4"/>
             <a:r>
-              <a:rPr lang="en-US" smtClean="0"/>
+              <a:rPr lang="en-US"/>
               <a:t>Fifth level</a:t>
             </a:r>
-            <a:endParaRPr lang="en-US"/>
           </a:p>
         </p:txBody>
       </p:sp>
@@ -1370,7 +1085,7 @@
           <a:p>
             <a:fld id="{5BCAD085-E8A6-8845-BD4E-CB4CCA059FC4}" type="datetimeFigureOut">
               <a:rPr lang="en-US" smtClean="0"/>
-              <a:t>1/27/13</a:t>
+              <a:t>9/16/26</a:t>
             </a:fld>
             <a:endParaRPr lang="en-US"/>
           </a:p>
@@ -1473,10 +1188,9 @@
           </a:lstStyle>
           <a:p>
             <a:r>
-              <a:rPr lang="en-US" smtClean="0"/>
+              <a:rPr lang="en-US"/>
               <a:t>Click to edit Master title style</a:t>
             </a:r>
-            <a:endParaRPr lang="en-US"/>
           </a:p>
         </p:txBody>
       </p:sp>
@@ -1593,7 +1307,7 @@
           <a:p>
             <a:pPr lvl="0"/>
             <a:r>
-              <a:rPr lang="en-US" smtClean="0"/>
+              <a:rPr lang="en-US"/>
               <a:t>Click to edit Master text styles</a:t>
             </a:r>
           </a:p>
@@ -1616,7 +1330,7 @@
           <a:p>
             <a:fld id="{5BCAD085-E8A6-8845-BD4E-CB4CCA059FC4}" type="datetimeFigureOut">
               <a:rPr lang="en-US" smtClean="0"/>
-              <a:t>1/27/13</a:t>
+              <a:t>9/16/26</a:t>
             </a:fld>
             <a:endParaRPr lang="en-US"/>
           </a:p>
@@ -1710,10 +1424,9 @@
           <a:lstStyle/>
           <a:p>
             <a:r>
-              <a:rPr lang="en-US" smtClean="0"/>
+              <a:rPr lang="en-US"/>
               <a:t>Click to edit Master title style</a:t>
             </a:r>
-            <a:endParaRPr lang="en-US"/>
           </a:p>
         </p:txBody>
       </p:sp>
@@ -1767,38 +1480,37 @@
           <a:p>
             <a:pPr lvl="0"/>
             <a:r>
-              <a:rPr lang="en-US" smtClean="0"/>
+              <a:rPr lang="en-US"/>
               <a:t>Click to edit Master text styles</a:t>
             </a:r>
           </a:p>
           <a:p>
             <a:pPr lvl="1"/>
             <a:r>
-              <a:rPr lang="en-US" smtClean="0"/>
+              <a:rPr lang="en-US"/>
               <a:t>Second level</a:t>
             </a:r>
           </a:p>
           <a:p>
             <a:pPr lvl="2"/>
             <a:r>
-              <a:rPr lang="en-US" smtClean="0"/>
+              <a:rPr lang="en-US"/>
               <a:t>Third level</a:t>
             </a:r>
           </a:p>
           <a:p>
             <a:pPr lvl="3"/>
             <a:r>
-              <a:rPr lang="en-US" smtClean="0"/>
+              <a:rPr lang="en-US"/>
               <a:t>Fourth level</a:t>
             </a:r>
           </a:p>
           <a:p>
             <a:pPr lvl="4"/>
             <a:r>
-              <a:rPr lang="en-US" smtClean="0"/>
+              <a:rPr lang="en-US"/>
               <a:t>Fifth level</a:t>
             </a:r>
-            <a:endParaRPr lang="en-US"/>
           </a:p>
         </p:txBody>
       </p:sp>
@@ -1852,38 +1564,37 @@
           <a:p>
             <a:pPr lvl="0"/>
             <a:r>
-              <a:rPr lang="en-US" smtClean="0"/>
+              <a:rPr lang="en-US"/>
               <a:t>Click to edit Master text styles</a:t>
             </a:r>
           </a:p>
           <a:p>
             <a:pPr lvl="1"/>
             <a:r>
-              <a:rPr lang="en-US" smtClean="0"/>
+              <a:rPr lang="en-US"/>
               <a:t>Second level</a:t>
             </a:r>
           </a:p>
           <a:p>
             <a:pPr lvl="2"/>
             <a:r>
-              <a:rPr lang="en-US" smtClean="0"/>
+              <a:rPr lang="en-US"/>
               <a:t>Third level</a:t>
             </a:r>
           </a:p>
           <a:p>
             <a:pPr lvl="3"/>
             <a:r>
-              <a:rPr lang="en-US" smtClean="0"/>
+              <a:rPr lang="en-US"/>
               <a:t>Fourth level</a:t>
             </a:r>
           </a:p>
           <a:p>
             <a:pPr lvl="4"/>
             <a:r>
-              <a:rPr lang="en-US" smtClean="0"/>
+              <a:rPr lang="en-US"/>
               <a:t>Fifth level</a:t>
             </a:r>
-            <a:endParaRPr lang="en-US"/>
           </a:p>
         </p:txBody>
       </p:sp>
@@ -1904,7 +1615,7 @@
           <a:p>
             <a:fld id="{5BCAD085-E8A6-8845-BD4E-CB4CCA059FC4}" type="datetimeFigureOut">
               <a:rPr lang="en-US" smtClean="0"/>
-              <a:t>1/27/13</a:t>
+              <a:t>9/16/26</a:t>
             </a:fld>
             <a:endParaRPr lang="en-US"/>
           </a:p>
@@ -2002,10 +1713,9 @@
           </a:lstStyle>
           <a:p>
             <a:r>
-              <a:rPr lang="en-US" smtClean="0"/>
+              <a:rPr lang="en-US"/>
               <a:t>Click to edit Master title style</a:t>
             </a:r>
-            <a:endParaRPr lang="en-US"/>
           </a:p>
         </p:txBody>
       </p:sp>
@@ -2068,7 +1778,7 @@
           <a:p>
             <a:pPr lvl="0"/>
             <a:r>
-              <a:rPr lang="en-US" smtClean="0"/>
+              <a:rPr lang="en-US"/>
               <a:t>Click to edit Master text styles</a:t>
             </a:r>
           </a:p>
@@ -2124,38 +1834,37 @@
           <a:p>
             <a:pPr lvl="0"/>
             <a:r>
-              <a:rPr lang="en-US" smtClean="0"/>
+              <a:rPr lang="en-US"/>
               <a:t>Click to edit Master text styles</a:t>
             </a:r>
           </a:p>
           <a:p>
             <a:pPr lvl="1"/>
             <a:r>
-              <a:rPr lang="en-US" smtClean="0"/>
+              <a:rPr lang="en-US"/>
               <a:t>Second level</a:t>
             </a:r>
           </a:p>
           <a:p>
             <a:pPr lvl="2"/>
             <a:r>
-              <a:rPr lang="en-US" smtClean="0"/>
+              <a:rPr lang="en-US"/>
               <a:t>Third level</a:t>
             </a:r>
           </a:p>
           <a:p>
             <a:pPr lvl="3"/>
             <a:r>
-              <a:rPr lang="en-US" smtClean="0"/>
+              <a:rPr lang="en-US"/>
               <a:t>Fourth level</a:t>
             </a:r>
           </a:p>
           <a:p>
             <a:pPr lvl="4"/>
             <a:r>
-              <a:rPr lang="en-US" smtClean="0"/>
+              <a:rPr lang="en-US"/>
               <a:t>Fifth level</a:t>
             </a:r>
-            <a:endParaRPr lang="en-US"/>
           </a:p>
         </p:txBody>
       </p:sp>
@@ -2218,7 +1927,7 @@
           <a:p>
             <a:pPr lvl="0"/>
             <a:r>
-              <a:rPr lang="en-US" smtClean="0"/>
+              <a:rPr lang="en-US"/>
               <a:t>Click to edit Master text styles</a:t>
             </a:r>
           </a:p>
@@ -2274,38 +1983,37 @@
           <a:p>
             <a:pPr lvl="0"/>
             <a:r>
-              <a:rPr lang="en-US" smtClean="0"/>
+              <a:rPr lang="en-US"/>
               <a:t>Click to edit Master text styles</a:t>
             </a:r>
           </a:p>
           <a:p>
             <a:pPr lvl="1"/>
             <a:r>
-              <a:rPr lang="en-US" smtClean="0"/>
+              <a:rPr lang="en-US"/>
               <a:t>Second level</a:t>
             </a:r>
           </a:p>
           <a:p>
             <a:pPr lvl="2"/>
             <a:r>
-              <a:rPr lang="en-US" smtClean="0"/>
+              <a:rPr lang="en-US"/>
               <a:t>Third level</a:t>
             </a:r>
           </a:p>
           <a:p>
             <a:pPr lvl="3"/>
             <a:r>
-              <a:rPr lang="en-US" smtClean="0"/>
+              <a:rPr lang="en-US"/>
               <a:t>Fourth level</a:t>
             </a:r>
           </a:p>
           <a:p>
             <a:pPr lvl="4"/>
             <a:r>
-              <a:rPr lang="en-US" smtClean="0"/>
+              <a:rPr lang="en-US"/>
               <a:t>Fifth level</a:t>
             </a:r>
-            <a:endParaRPr lang="en-US"/>
           </a:p>
         </p:txBody>
       </p:sp>
@@ -2326,7 +2034,7 @@
           <a:p>
             <a:fld id="{5BCAD085-E8A6-8845-BD4E-CB4CCA059FC4}" type="datetimeFigureOut">
               <a:rPr lang="en-US" smtClean="0"/>
-              <a:t>1/27/13</a:t>
+              <a:t>9/16/26</a:t>
             </a:fld>
             <a:endParaRPr lang="en-US"/>
           </a:p>
@@ -2420,10 +2128,9 @@
           <a:lstStyle/>
           <a:p>
             <a:r>
-              <a:rPr lang="en-US" smtClean="0"/>
+              <a:rPr lang="en-US"/>
               <a:t>Click to edit Master title style</a:t>
             </a:r>
-            <a:endParaRPr lang="en-US"/>
           </a:p>
         </p:txBody>
       </p:sp>
@@ -2444,7 +2151,7 @@
           <a:p>
             <a:fld id="{5BCAD085-E8A6-8845-BD4E-CB4CCA059FC4}" type="datetimeFigureOut">
               <a:rPr lang="en-US" smtClean="0"/>
-              <a:t>1/27/13</a:t>
+              <a:t>9/16/26</a:t>
             </a:fld>
             <a:endParaRPr lang="en-US"/>
           </a:p>
@@ -2539,7 +2246,7 @@
           <a:p>
             <a:fld id="{5BCAD085-E8A6-8845-BD4E-CB4CCA059FC4}" type="datetimeFigureOut">
               <a:rPr lang="en-US" smtClean="0"/>
-              <a:t>1/27/13</a:t>
+              <a:t>9/16/26</a:t>
             </a:fld>
             <a:endParaRPr lang="en-US"/>
           </a:p>
@@ -2642,10 +2349,9 @@
           </a:lstStyle>
           <a:p>
             <a:r>
-              <a:rPr lang="en-US" smtClean="0"/>
+              <a:rPr lang="en-US"/>
               <a:t>Click to edit Master title style</a:t>
             </a:r>
-            <a:endParaRPr lang="en-US"/>
           </a:p>
         </p:txBody>
       </p:sp>
@@ -2699,38 +2405,37 @@
           <a:p>
             <a:pPr lvl="0"/>
             <a:r>
-              <a:rPr lang="en-US" smtClean="0"/>
+              <a:rPr lang="en-US"/>
               <a:t>Click to edit Master text styles</a:t>
             </a:r>
           </a:p>
           <a:p>
             <a:pPr lvl="1"/>
             <a:r>
-              <a:rPr lang="en-US" smtClean="0"/>
+              <a:rPr lang="en-US"/>
               <a:t>Second level</a:t>
             </a:r>
           </a:p>
           <a:p>
             <a:pPr lvl="2"/>
             <a:r>
-              <a:rPr lang="en-US" smtClean="0"/>
+              <a:rPr lang="en-US"/>
               <a:t>Third level</a:t>
             </a:r>
           </a:p>
           <a:p>
             <a:pPr lvl="3"/>
             <a:r>
-              <a:rPr lang="en-US" smtClean="0"/>
+              <a:rPr lang="en-US"/>
               <a:t>Fourth level</a:t>
             </a:r>
           </a:p>
           <a:p>
             <a:pPr lvl="4"/>
             <a:r>
-              <a:rPr lang="en-US" smtClean="0"/>
+              <a:rPr lang="en-US"/>
               <a:t>Fifth level</a:t>
             </a:r>
-            <a:endParaRPr lang="en-US"/>
           </a:p>
         </p:txBody>
       </p:sp>
@@ -2793,7 +2498,7 @@
           <a:p>
             <a:pPr lvl="0"/>
             <a:r>
-              <a:rPr lang="en-US" smtClean="0"/>
+              <a:rPr lang="en-US"/>
               <a:t>Click to edit Master text styles</a:t>
             </a:r>
           </a:p>
@@ -2816,7 +2521,7 @@
           <a:p>
             <a:fld id="{5BCAD085-E8A6-8845-BD4E-CB4CCA059FC4}" type="datetimeFigureOut">
               <a:rPr lang="en-US" smtClean="0"/>
-              <a:t>1/27/13</a:t>
+              <a:t>9/16/26</a:t>
             </a:fld>
             <a:endParaRPr lang="en-US"/>
           </a:p>
@@ -2919,10 +2624,9 @@
           </a:lstStyle>
           <a:p>
             <a:r>
-              <a:rPr lang="en-US" smtClean="0"/>
+              <a:rPr lang="en-US"/>
               <a:t>Click to edit Master title style</a:t>
             </a:r>
-            <a:endParaRPr lang="en-US"/>
           </a:p>
         </p:txBody>
       </p:sp>
@@ -3046,7 +2750,7 @@
           <a:p>
             <a:pPr lvl="0"/>
             <a:r>
-              <a:rPr lang="en-US" smtClean="0"/>
+              <a:rPr lang="en-US"/>
               <a:t>Click to edit Master text styles</a:t>
             </a:r>
           </a:p>
@@ -3069,7 +2773,7 @@
           <a:p>
             <a:fld id="{5BCAD085-E8A6-8845-BD4E-CB4CCA059FC4}" type="datetimeFigureOut">
               <a:rPr lang="en-US" smtClean="0"/>
-              <a:t>1/27/13</a:t>
+              <a:t>9/16/26</a:t>
             </a:fld>
             <a:endParaRPr lang="en-US"/>
           </a:p>
@@ -3178,10 +2882,9 @@
           <a:lstStyle/>
           <a:p>
             <a:r>
-              <a:rPr lang="en-US" smtClean="0"/>
+              <a:rPr lang="en-US"/>
               <a:t>Click to edit Master title style</a:t>
             </a:r>
-            <a:endParaRPr lang="en-US"/>
           </a:p>
         </p:txBody>
       </p:sp>
@@ -3212,38 +2915,37 @@
           <a:p>
             <a:pPr lvl="0"/>
             <a:r>
-              <a:rPr lang="en-US" smtClean="0"/>
+              <a:rPr lang="en-US"/>
               <a:t>Click to edit Master text styles</a:t>
             </a:r>
           </a:p>
           <a:p>
             <a:pPr lvl="1"/>
             <a:r>
-              <a:rPr lang="en-US" smtClean="0"/>
+              <a:rPr lang="en-US"/>
               <a:t>Second level</a:t>
             </a:r>
           </a:p>
           <a:p>
             <a:pPr lvl="2"/>
             <a:r>
-              <a:rPr lang="en-US" smtClean="0"/>
+              <a:rPr lang="en-US"/>
               <a:t>Third level</a:t>
             </a:r>
           </a:p>
           <a:p>
             <a:pPr lvl="3"/>
             <a:r>
-              <a:rPr lang="en-US" smtClean="0"/>
+              <a:rPr lang="en-US"/>
               <a:t>Fourth level</a:t>
             </a:r>
           </a:p>
           <a:p>
             <a:pPr lvl="4"/>
             <a:r>
-              <a:rPr lang="en-US" smtClean="0"/>
+              <a:rPr lang="en-US"/>
               <a:t>Fifth level</a:t>
             </a:r>
-            <a:endParaRPr lang="en-US"/>
           </a:p>
         </p:txBody>
       </p:sp>
@@ -3282,7 +2984,7 @@
           <a:p>
             <a:fld id="{5BCAD085-E8A6-8845-BD4E-CB4CCA059FC4}" type="datetimeFigureOut">
               <a:rPr lang="en-US" smtClean="0"/>
-              <a:t>1/27/13</a:t>
+              <a:t>9/16/26</a:t>
             </a:fld>
             <a:endParaRPr lang="en-US"/>
           </a:p>
@@ -3641,7 +3343,7 @@
 </file>
 
 <file path=ppt/slides/slide1.xml><?xml version="1.0" encoding="utf-8"?>
-<p:sld xmlns:a="http://schemas.openxmlformats.org/drawingml/2006/main" xmlns:p="http://schemas.openxmlformats.org/presentationml/2006/main" xmlns:r="http://schemas.openxmlformats.org/officeDocument/2006/relationships">
+<p:sld xmlns:a="http://schemas.openxmlformats.org/drawingml/2006/main" xmlns:r="http://schemas.openxmlformats.org/officeDocument/2006/relationships" xmlns:p="http://schemas.openxmlformats.org/presentationml/2006/main">
   <p:cSld>
     <p:spTree>
       <p:nvGrpSpPr>
@@ -3649,7 +3351,14 @@
         <p:cNvGrpSpPr/>
         <p:nvPr/>
       </p:nvGrpSpPr>
-      <p:grpSpPr/>
+      <p:grpSpPr>
+        <a:xfrm>
+          <a:off x="0" y="0"/>
+          <a:ext cx="0" cy="0"/>
+          <a:chOff x="0" y="0"/>
+          <a:chExt cx="0" cy="0"/>
+        </a:xfrm>
+      </p:grpSpPr>
       <p:sp>
         <p:nvSpPr>
           <p:cNvPr id="2" name="TextBox 1"/>
@@ -3667,7 +3376,7 @@
           <a:noFill/>
         </p:spPr>
         <p:txBody>
-          <a:bodyPr wrap="none" lIns="0" rIns="0" tIns="0" bIns="0">
+          <a:bodyPr wrap="none" lIns="0" tIns="0" rIns="0" bIns="0">
             <a:spAutoFit/>
           </a:bodyPr>
           <a:lstStyle/>
@@ -3701,7 +3410,7 @@
           <a:noFill/>
         </p:spPr>
         <p:txBody>
-          <a:bodyPr wrap="square" lIns="0" rIns="0" tIns="0" bIns="0">
+          <a:bodyPr wrap="square" lIns="0" tIns="0" rIns="0" bIns="0">
             <a:spAutoFit/>
           </a:bodyPr>
           <a:lstStyle/>
@@ -3735,12 +3444,12 @@
           <a:noFill/>
         </p:spPr>
         <p:txBody>
-          <a:bodyPr wrap="square" lIns="0" rIns="0" tIns="0" bIns="0">
+          <a:bodyPr wrap="square" lIns="0" tIns="0" rIns="0" bIns="0">
             <a:spAutoFit/>
           </a:bodyPr>
           <a:lstStyle/>
           <a:p>
-            <a:pPr algn="l" marL="182880" indent="-182880">
+            <a:pPr marL="182880" indent="-182880" algn="l">
               <a:lnSpc>
                 <a:spcPts val="1900"/>
               </a:lnSpc>
@@ -3750,7 +3459,7 @@
               <a:buNone/>
             </a:pPr>
             <a:r>
-              <a:rPr sz="1400" b="0" i="0">
+              <a:rPr sz="1400" b="0" i="0" dirty="0">
                 <a:solidFill>
                   <a:srgbClr val="262626"/>
                 </a:solidFill>
@@ -3760,7 +3469,7 @@
             </a:r>
           </a:p>
           <a:p>
-            <a:pPr algn="l" marL="182880" indent="-182880">
+            <a:pPr marL="182880" indent="-182880" algn="l">
               <a:lnSpc>
                 <a:spcPts val="1900"/>
               </a:lnSpc>
@@ -3770,7 +3479,7 @@
               <a:buNone/>
             </a:pPr>
             <a:r>
-              <a:rPr sz="1400" b="0" i="0">
+              <a:rPr sz="1400" b="0" i="0" dirty="0">
                 <a:solidFill>
                   <a:srgbClr val="262626"/>
                 </a:solidFill>
@@ -3780,7 +3489,7 @@
             </a:r>
           </a:p>
           <a:p>
-            <a:pPr algn="l" marL="182880" indent="-182880">
+            <a:pPr marL="182880" indent="-182880" algn="l">
               <a:lnSpc>
                 <a:spcPts val="1900"/>
               </a:lnSpc>
@@ -3790,7 +3499,7 @@
               <a:buNone/>
             </a:pPr>
             <a:r>
-              <a:rPr sz="1400" b="0" i="0">
+              <a:rPr sz="1400" b="0" i="0" dirty="0">
                 <a:solidFill>
                   <a:srgbClr val="262626"/>
                 </a:solidFill>
@@ -3800,7 +3509,7 @@
             </a:r>
           </a:p>
           <a:p>
-            <a:pPr algn="l" marL="182880" indent="-182880">
+            <a:pPr marL="182880" indent="-182880" algn="l">
               <a:lnSpc>
                 <a:spcPts val="1900"/>
               </a:lnSpc>
@@ -3810,7 +3519,7 @@
               <a:buNone/>
             </a:pPr>
             <a:r>
-              <a:rPr sz="1400" b="0" i="0">
+              <a:rPr sz="1400" b="0" i="0" dirty="0">
                 <a:solidFill>
                   <a:srgbClr val="262626"/>
                 </a:solidFill>
@@ -3820,7 +3529,7 @@
             </a:r>
           </a:p>
           <a:p>
-            <a:pPr algn="l" marL="182880" indent="-182880">
+            <a:pPr marL="182880" indent="-182880" algn="l">
               <a:lnSpc>
                 <a:spcPts val="1900"/>
               </a:lnSpc>
@@ -3830,7 +3539,7 @@
               <a:buNone/>
             </a:pPr>
             <a:r>
-              <a:rPr sz="1400" b="0" i="0">
+              <a:rPr sz="1400" b="0" i="0" dirty="0">
                 <a:solidFill>
                   <a:srgbClr val="262626"/>
                 </a:solidFill>
@@ -3840,7 +3549,7 @@
             </a:r>
           </a:p>
           <a:p>
-            <a:pPr algn="l" marL="182880" indent="-182880">
+            <a:pPr marL="182880" indent="-182880" algn="l">
               <a:lnSpc>
                 <a:spcPts val="1900"/>
               </a:lnSpc>
@@ -3850,7 +3559,7 @@
               <a:buNone/>
             </a:pPr>
             <a:r>
-              <a:rPr sz="1400" b="0" i="0">
+              <a:rPr sz="1400" b="0" i="0" dirty="0">
                 <a:solidFill>
                   <a:srgbClr val="262626"/>
                 </a:solidFill>
@@ -3870,7 +3579,7 @@
 </file>
 
 <file path=ppt/slides/slide2.xml><?xml version="1.0" encoding="utf-8"?>
-<p:sld xmlns:a="http://schemas.openxmlformats.org/drawingml/2006/main" xmlns:p="http://schemas.openxmlformats.org/presentationml/2006/main" xmlns:r="http://schemas.openxmlformats.org/officeDocument/2006/relationships">
+<p:sld xmlns:a="http://schemas.openxmlformats.org/drawingml/2006/main" xmlns:r="http://schemas.openxmlformats.org/officeDocument/2006/relationships" xmlns:p="http://schemas.openxmlformats.org/presentationml/2006/main">
   <p:cSld>
     <p:spTree>
       <p:nvGrpSpPr>
@@ -3878,7 +3587,14 @@
         <p:cNvGrpSpPr/>
         <p:nvPr/>
       </p:nvGrpSpPr>
-      <p:grpSpPr/>
+      <p:grpSpPr>
+        <a:xfrm>
+          <a:off x="0" y="0"/>
+          <a:ext cx="0" cy="0"/>
+          <a:chOff x="0" y="0"/>
+          <a:chExt cx="0" cy="0"/>
+        </a:xfrm>
+      </p:grpSpPr>
       <p:sp>
         <p:nvSpPr>
           <p:cNvPr id="2" name="TextBox 1"/>
@@ -3896,7 +3612,7 @@
           <a:noFill/>
         </p:spPr>
         <p:txBody>
-          <a:bodyPr wrap="none" lIns="0" rIns="0" tIns="0" bIns="0">
+          <a:bodyPr wrap="none" lIns="0" tIns="0" rIns="0" bIns="0">
             <a:spAutoFit/>
           </a:bodyPr>
           <a:lstStyle/>
@@ -3930,7 +3646,7 @@
           <a:noFill/>
         </p:spPr>
         <p:txBody>
-          <a:bodyPr wrap="square" lIns="0" rIns="0" tIns="0" bIns="0">
+          <a:bodyPr wrap="square" lIns="0" tIns="0" rIns="0" bIns="0">
             <a:spAutoFit/>
           </a:bodyPr>
           <a:lstStyle/>
@@ -3964,7 +3680,7 @@
           <a:noFill/>
         </p:spPr>
         <p:txBody>
-          <a:bodyPr wrap="square" lIns="0" rIns="0" tIns="0" bIns="0">
+          <a:bodyPr wrap="square" lIns="0" tIns="0" rIns="0" bIns="0">
             <a:spAutoFit/>
           </a:bodyPr>
           <a:lstStyle/>
@@ -4015,7 +3731,7 @@
           <a:noFill/>
         </p:spPr>
         <p:txBody>
-          <a:bodyPr wrap="square" lIns="0" rIns="0" tIns="0" bIns="0">
+          <a:bodyPr wrap="square" lIns="0" tIns="0" rIns="0" bIns="0">
             <a:spAutoFit/>
           </a:bodyPr>
           <a:lstStyle/>
@@ -4197,7 +3913,7 @@
           <a:noFill/>
         </p:spPr>
         <p:txBody>
-          <a:bodyPr wrap="square" lIns="0" rIns="0" tIns="0" bIns="0">
+          <a:bodyPr wrap="square" lIns="0" tIns="0" rIns="0" bIns="0">
             <a:spAutoFit/>
           </a:bodyPr>
           <a:lstStyle/>
@@ -4218,374 +3934,6 @@
                 <a:latin typeface="Calibri"/>
               </a:rPr>
               <a:t>We've started on a more detailed version of this. Rather than asking you “what should go in the GGM chapter”, we'd rather write up a proper outline and bring it to you — easier for you to react to, and you get to see what we're actually thinking. Hoping to have that ready over the coming week.</a:t>
-            </a:r>
-          </a:p>
-        </p:txBody>
-      </p:sp>
-    </p:spTree>
-  </p:cSld>
-  <p:clrMapOvr>
-    <a:masterClrMapping/>
-  </p:clrMapOvr>
-</p:sld>
-</file>
-
-<file path=ppt/slides/slide3.xml><?xml version="1.0" encoding="utf-8"?>
-<p:sld xmlns:a="http://schemas.openxmlformats.org/drawingml/2006/main" xmlns:p="http://schemas.openxmlformats.org/presentationml/2006/main" xmlns:r="http://schemas.openxmlformats.org/officeDocument/2006/relationships">
-  <p:cSld>
-    <p:spTree>
-      <p:nvGrpSpPr>
-        <p:cNvPr id="1" name=""/>
-        <p:cNvGrpSpPr/>
-        <p:nvPr/>
-      </p:nvGrpSpPr>
-      <p:grpSpPr/>
-      <p:sp>
-        <p:nvSpPr>
-          <p:cNvPr id="2" name="TextBox 1"/>
-          <p:cNvSpPr txBox="1"/>
-          <p:nvPr/>
-        </p:nvSpPr>
-        <p:spPr>
-          <a:xfrm>
-            <a:off x="731520" y="347472"/>
-            <a:ext cx="10698480" cy="237744"/>
-          </a:xfrm>
-          <a:prstGeom prst="rect">
-            <a:avLst/>
-          </a:prstGeom>
-          <a:noFill/>
-        </p:spPr>
-        <p:txBody>
-          <a:bodyPr wrap="none" lIns="0" rIns="0" tIns="0" bIns="0">
-            <a:spAutoFit/>
-          </a:bodyPr>
-          <a:lstStyle/>
-          <a:p>
-            <a:r>
-              <a:rPr sz="1300" b="0">
-                <a:solidFill>
-                  <a:srgbClr val="666666"/>
-                </a:solidFill>
-                <a:latin typeface="Calibri"/>
-              </a:rPr>
-              <a:t>Week 38</a:t>
-            </a:r>
-          </a:p>
-        </p:txBody>
-      </p:sp>
-      <p:sp>
-        <p:nvSpPr>
-          <p:cNvPr id="3" name="TextBox 2"/>
-          <p:cNvSpPr txBox="1"/>
-          <p:nvPr/>
-        </p:nvSpPr>
-        <p:spPr>
-          <a:xfrm>
-            <a:off x="731520" y="621792"/>
-            <a:ext cx="10698480" cy="457200"/>
-          </a:xfrm>
-          <a:prstGeom prst="rect">
-            <a:avLst/>
-          </a:prstGeom>
-          <a:noFill/>
-        </p:spPr>
-        <p:txBody>
-          <a:bodyPr wrap="square" lIns="0" rIns="0" tIns="0" bIns="0">
-            <a:spAutoFit/>
-          </a:bodyPr>
-          <a:lstStyle/>
-          <a:p>
-            <a:r>
-              <a:rPr sz="2700" b="1">
-                <a:solidFill>
-                  <a:srgbClr val="262626"/>
-                </a:solidFill>
-                <a:latin typeface="Calibri"/>
-              </a:rPr>
-              <a:t>What we'd like from you</a:t>
-            </a:r>
-          </a:p>
-        </p:txBody>
-      </p:sp>
-      <p:sp>
-        <p:nvSpPr>
-          <p:cNvPr id="4" name="TextBox 3"/>
-          <p:cNvSpPr txBox="1"/>
-          <p:nvPr/>
-        </p:nvSpPr>
-        <p:spPr>
-          <a:xfrm>
-            <a:off x="731520" y="1325880"/>
-            <a:ext cx="10698480" cy="2286000"/>
-          </a:xfrm>
-          <a:prstGeom prst="rect">
-            <a:avLst/>
-          </a:prstGeom>
-          <a:noFill/>
-        </p:spPr>
-        <p:txBody>
-          <a:bodyPr wrap="square" lIns="0" rIns="0" tIns="0" bIns="0">
-            <a:spAutoFit/>
-          </a:bodyPr>
-          <a:lstStyle/>
-          <a:p>
-            <a:pPr algn="l">
-              <a:lnSpc>
-                <a:spcPts val="1800"/>
-              </a:lnSpc>
-              <a:spcAft>
-                <a:spcPts val="300"/>
-              </a:spcAft>
-            </a:pPr>
-            <a:r>
-              <a:rPr sz="1600" b="1" i="0">
-                <a:solidFill>
-                  <a:srgbClr val="262626"/>
-                </a:solidFill>
-                <a:latin typeface="Calibri"/>
-              </a:rPr>
-              <a:t>1.  Have we understood the configuration correctly?</a:t>
-            </a:r>
-          </a:p>
-          <a:p>
-            <a:pPr algn="l">
-              <a:lnSpc>
-                <a:spcPts val="1800"/>
-              </a:lnSpc>
-              <a:spcAft>
-                <a:spcPts val="300"/>
-              </a:spcAft>
-            </a:pPr>
-            <a:r>
-              <a:rPr sz="1350" b="0" i="0">
-                <a:solidFill>
-                  <a:srgbClr val="262626"/>
-                </a:solidFill>
-                <a:latin typeface="Calibri"/>
-              </a:rPr>
-              <a:t>Our current reading is that the inputs come in four kinds:</a:t>
-            </a:r>
-          </a:p>
-          <a:p>
-            <a:pPr algn="l" marL="182880" indent="-182880">
-              <a:lnSpc>
-                <a:spcPts val="1800"/>
-              </a:lnSpc>
-              <a:spcAft>
-                <a:spcPts val="300"/>
-              </a:spcAft>
-              <a:buNone/>
-            </a:pPr>
-            <a:r>
-              <a:rPr sz="1350" b="0" i="0">
-                <a:solidFill>
-                  <a:srgbClr val="262626"/>
-                </a:solidFill>
-                <a:latin typeface="Calibri"/>
-              </a:rPr>
-              <a:t>–  physical facts — pipeline, LNG and storage capacities, collected from ENTSOG, EIA, GIIGNL</a:t>
-            </a:r>
-          </a:p>
-          <a:p>
-            <a:pPr algn="l" marL="182880" indent="-182880">
-              <a:lnSpc>
-                <a:spcPts val="1800"/>
-              </a:lnSpc>
-              <a:spcAft>
-                <a:spcPts val="300"/>
-              </a:spcAft>
-              <a:buNone/>
-            </a:pPr>
-            <a:r>
-              <a:rPr sz="1350" b="0" i="0">
-                <a:solidFill>
-                  <a:srgbClr val="262626"/>
-                </a:solidFill>
-                <a:latin typeface="Calibri"/>
-              </a:rPr>
-              <a:t>–  projections — production and consumption read off a chosen WEO or PRIMES outlook</a:t>
-            </a:r>
-          </a:p>
-          <a:p>
-            <a:pPr algn="l" marL="182880" indent="-182880">
-              <a:lnSpc>
-                <a:spcPts val="1800"/>
-              </a:lnSpc>
-              <a:spcAft>
-                <a:spcPts val="300"/>
-              </a:spcAft>
-              <a:buNone/>
-            </a:pPr>
-            <a:r>
-              <a:rPr sz="1350" b="0" i="0">
-                <a:solidFill>
-                  <a:srgbClr val="262626"/>
-                </a:solidFill>
-                <a:latin typeface="Calibri"/>
-              </a:rPr>
-              <a:t>–  literature parameters — elasticities, base costs, set once and rarely touched</a:t>
-            </a:r>
-          </a:p>
-          <a:p>
-            <a:pPr algn="l" marL="182880" indent="-182880">
-              <a:lnSpc>
-                <a:spcPts val="1800"/>
-              </a:lnSpc>
-              <a:spcAft>
-                <a:spcPts val="300"/>
-              </a:spcAft>
-              <a:buNone/>
-            </a:pPr>
-            <a:r>
-              <a:rPr sz="1350" b="0" i="0">
-                <a:solidFill>
-                  <a:srgbClr val="262626"/>
-                </a:solidFill>
-                <a:latin typeface="Calibri"/>
-              </a:rPr>
-              <a:t>–  calibrated values — not collected anywhere, you tune them until the model matches reality</a:t>
-            </a:r>
-          </a:p>
-          <a:p>
-            <a:pPr algn="l">
-              <a:lnSpc>
-                <a:spcPts val="1800"/>
-              </a:lnSpc>
-              <a:spcAft>
-                <a:spcPts val="300"/>
-              </a:spcAft>
-            </a:pPr>
-            <a:r>
-              <a:rPr sz="1350" b="0" i="1">
-                <a:solidFill>
-                  <a:srgbClr val="262626"/>
-                </a:solidFill>
-                <a:latin typeface="Calibri"/>
-              </a:rPr>
-              <a:t>Is that roughly how you think about it?</a:t>
-            </a:r>
-          </a:p>
-        </p:txBody>
-      </p:sp>
-      <p:sp>
-        <p:nvSpPr>
-          <p:cNvPr id="5" name="TextBox 4"/>
-          <p:cNvSpPr txBox="1"/>
-          <p:nvPr/>
-        </p:nvSpPr>
-        <p:spPr>
-          <a:xfrm>
-            <a:off x="731520" y="3977639"/>
-            <a:ext cx="10698480" cy="1005840"/>
-          </a:xfrm>
-          <a:prstGeom prst="rect">
-            <a:avLst/>
-          </a:prstGeom>
-          <a:noFill/>
-        </p:spPr>
-        <p:txBody>
-          <a:bodyPr wrap="square" lIns="0" rIns="0" tIns="0" bIns="0">
-            <a:spAutoFit/>
-          </a:bodyPr>
-          <a:lstStyle/>
-          <a:p>
-            <a:pPr algn="l">
-              <a:lnSpc>
-                <a:spcPts val="1800"/>
-              </a:lnSpc>
-              <a:spcAft>
-                <a:spcPts val="400"/>
-              </a:spcAft>
-            </a:pPr>
-            <a:r>
-              <a:rPr sz="1600" b="1" i="0">
-                <a:solidFill>
-                  <a:srgbClr val="262626"/>
-                </a:solidFill>
-                <a:latin typeface="Calibri"/>
-              </a:rPr>
-              <a:t>2.  How does calibration actually work in practice?</a:t>
-            </a:r>
-          </a:p>
-          <a:p>
-            <a:pPr algn="l">
-              <a:lnSpc>
-                <a:spcPts val="1800"/>
-              </a:lnSpc>
-              <a:spcAft>
-                <a:spcPts val="400"/>
-              </a:spcAft>
-            </a:pPr>
-            <a:r>
-              <a:rPr sz="1350" b="0" i="0">
-                <a:solidFill>
-                  <a:srgbClr val="262626"/>
-                </a:solidFill>
-                <a:latin typeface="Calibri"/>
-              </a:rPr>
-              <a:t>The documentation says days to weeks for an experienced analyst, but not what you actually do. Could we walk through tuning one parameter — where you start, how you pick between the possible causes, and how you know when to stop?</a:t>
-            </a:r>
-          </a:p>
-        </p:txBody>
-      </p:sp>
-      <p:sp>
-        <p:nvSpPr>
-          <p:cNvPr id="6" name="TextBox 5"/>
-          <p:cNvSpPr txBox="1"/>
-          <p:nvPr/>
-        </p:nvSpPr>
-        <p:spPr>
-          <a:xfrm>
-            <a:off x="731520" y="5349240"/>
-            <a:ext cx="10698480" cy="914400"/>
-          </a:xfrm>
-          <a:prstGeom prst="rect">
-            <a:avLst/>
-          </a:prstGeom>
-          <a:noFill/>
-        </p:spPr>
-        <p:txBody>
-          <a:bodyPr wrap="square" lIns="0" rIns="0" tIns="0" bIns="0">
-            <a:spAutoFit/>
-          </a:bodyPr>
-          <a:lstStyle/>
-          <a:p>
-            <a:pPr algn="l">
-              <a:lnSpc>
-                <a:spcPts val="1800"/>
-              </a:lnSpc>
-              <a:spcAft>
-                <a:spcPts val="400"/>
-              </a:spcAft>
-            </a:pPr>
-            <a:r>
-              <a:rPr sz="1600" b="1" i="0">
-                <a:solidFill>
-                  <a:srgbClr val="262626"/>
-                </a:solidFill>
-                <a:latin typeface="Calibri"/>
-              </a:rPr>
-              <a:t>3.  Does the structure look sensible?</a:t>
-            </a:r>
-          </a:p>
-          <a:p>
-            <a:pPr algn="l">
-              <a:lnSpc>
-                <a:spcPts val="1800"/>
-              </a:lnSpc>
-              <a:spcAft>
-                <a:spcPts val="400"/>
-              </a:spcAft>
-            </a:pPr>
-            <a:r>
-              <a:rPr sz="1350" b="0" i="0">
-                <a:solidFill>
-                  <a:srgbClr val="262626"/>
-                </a:solidFill>
-                <a:latin typeface="Calibri"/>
-              </a:rPr>
-              <a:t>Mainly: how narrow should the research question be, and do you want a proof of concept, or is the exploration enough on its own?</a:t>
             </a:r>
           </a:p>
         </p:txBody>
@@ -4919,7 +4267,7 @@
 </file>
 
 <file path=ppt/theme/theme2.xml><?xml version="1.0" encoding="utf-8"?>
-<a:theme xmlns:a="http://schemas.openxmlformats.org/drawingml/2006/main" name="Office Theme">
+<a:theme xmlns:a="http://schemas.openxmlformats.org/drawingml/2006/main" name="Office-tema">
   <a:themeElements>
     <a:clrScheme name="Office">
       <a:dk1>
@@ -4929,44 +4277,44 @@
         <a:sysClr val="window" lastClr="FFFFFF"/>
       </a:lt1>
       <a:dk2>
-        <a:srgbClr val="1F497D"/>
+        <a:srgbClr val="0E2841"/>
       </a:dk2>
       <a:lt2>
-        <a:srgbClr val="EEECE1"/>
+        <a:srgbClr val="E8E8E8"/>
       </a:lt2>
       <a:accent1>
-        <a:srgbClr val="4F81BD"/>
+        <a:srgbClr val="156082"/>
       </a:accent1>
       <a:accent2>
-        <a:srgbClr val="C0504D"/>
+        <a:srgbClr val="E97132"/>
       </a:accent2>
       <a:accent3>
-        <a:srgbClr val="9BBB59"/>
+        <a:srgbClr val="196B24"/>
       </a:accent3>
       <a:accent4>
-        <a:srgbClr val="8064A2"/>
+        <a:srgbClr val="0F9ED5"/>
       </a:accent4>
       <a:accent5>
-        <a:srgbClr val="4BACC6"/>
+        <a:srgbClr val="A02B93"/>
       </a:accent5>
       <a:accent6>
-        <a:srgbClr val="F79646"/>
+        <a:srgbClr val="4EA72E"/>
       </a:accent6>
       <a:hlink>
-        <a:srgbClr val="0000FF"/>
+        <a:srgbClr val="467886"/>
       </a:hlink>
       <a:folHlink>
-        <a:srgbClr val="800080"/>
+        <a:srgbClr val="96607D"/>
       </a:folHlink>
     </a:clrScheme>
     <a:fontScheme name="Office">
       <a:majorFont>
-        <a:latin typeface="Calibri"/>
+        <a:latin typeface="Aptos Display" panose="02110004020202020204"/>
         <a:ea typeface=""/>
         <a:cs typeface=""/>
-        <a:font script="Jpan" typeface="ＭＳ Ｐゴシック"/>
+        <a:font script="Jpan" typeface="游ゴシック Light"/>
         <a:font script="Hang" typeface="맑은 고딕"/>
-        <a:font script="Hans" typeface="宋体"/>
+        <a:font script="Hans" typeface="等线 Light"/>
         <a:font script="Hant" typeface="新細明體"/>
         <a:font script="Arab" typeface="Times New Roman"/>
         <a:font script="Hebr" typeface="Times New Roman"/>
@@ -4994,14 +4342,31 @@
         <a:font script="Viet" typeface="Times New Roman"/>
         <a:font script="Uigh" typeface="Microsoft Uighur"/>
         <a:font script="Geor" typeface="Sylfaen"/>
+        <a:font script="Armn" typeface="Arial"/>
+        <a:font script="Bugi" typeface="Leelawadee UI"/>
+        <a:font script="Bopo" typeface="Microsoft JhengHei"/>
+        <a:font script="Java" typeface="Javanese Text"/>
+        <a:font script="Lisu" typeface="Segoe UI"/>
+        <a:font script="Mymr" typeface="Myanmar Text"/>
+        <a:font script="Nkoo" typeface="Ebrima"/>
+        <a:font script="Olck" typeface="Nirmala UI"/>
+        <a:font script="Osma" typeface="Ebrima"/>
+        <a:font script="Phag" typeface="Phagspa"/>
+        <a:font script="Syrn" typeface="Estrangelo Edessa"/>
+        <a:font script="Syrj" typeface="Estrangelo Edessa"/>
+        <a:font script="Syre" typeface="Estrangelo Edessa"/>
+        <a:font script="Sora" typeface="Nirmala UI"/>
+        <a:font script="Tale" typeface="Microsoft Tai Le"/>
+        <a:font script="Talu" typeface="Microsoft New Tai Lue"/>
+        <a:font script="Tfng" typeface="Ebrima"/>
       </a:majorFont>
       <a:minorFont>
-        <a:latin typeface="Calibri"/>
+        <a:latin typeface="Aptos" panose="02110004020202020204"/>
         <a:ea typeface=""/>
         <a:cs typeface=""/>
-        <a:font script="Jpan" typeface="ＭＳ Ｐゴシック"/>
+        <a:font script="Jpan" typeface="游ゴシック"/>
         <a:font script="Hang" typeface="맑은 고딕"/>
-        <a:font script="Hans" typeface="宋体"/>
+        <a:font script="Hans" typeface="等线"/>
         <a:font script="Hant" typeface="新細明體"/>
         <a:font script="Arab" typeface="Arial"/>
         <a:font script="Hebr" typeface="Arial"/>
@@ -5029,6 +4394,23 @@
         <a:font script="Viet" typeface="Arial"/>
         <a:font script="Uigh" typeface="Microsoft Uighur"/>
         <a:font script="Geor" typeface="Sylfaen"/>
+        <a:font script="Armn" typeface="Arial"/>
+        <a:font script="Bugi" typeface="Leelawadee UI"/>
+        <a:font script="Bopo" typeface="Microsoft JhengHei"/>
+        <a:font script="Java" typeface="Javanese Text"/>
+        <a:font script="Lisu" typeface="Segoe UI"/>
+        <a:font script="Mymr" typeface="Myanmar Text"/>
+        <a:font script="Nkoo" typeface="Ebrima"/>
+        <a:font script="Olck" typeface="Nirmala UI"/>
+        <a:font script="Osma" typeface="Ebrima"/>
+        <a:font script="Phag" typeface="Phagspa"/>
+        <a:font script="Syrn" typeface="Estrangelo Edessa"/>
+        <a:font script="Syrj" typeface="Estrangelo Edessa"/>
+        <a:font script="Syre" typeface="Estrangelo Edessa"/>
+        <a:font script="Sora" typeface="Nirmala UI"/>
+        <a:font script="Tale" typeface="Microsoft Tai Le"/>
+        <a:font script="Talu" typeface="Microsoft New Tai Lue"/>
+        <a:font script="Tfng" typeface="Ebrima"/>
       </a:minorFont>
     </a:fontScheme>
     <a:fmtScheme name="Office">
@@ -5040,180 +4422,136 @@
           <a:gsLst>
             <a:gs pos="0">
               <a:schemeClr val="phClr">
-                <a:tint val="50000"/>
-                <a:satMod val="300000"/>
+                <a:lumMod val="110000"/>
+                <a:satMod val="105000"/>
+                <a:tint val="67000"/>
               </a:schemeClr>
             </a:gs>
-            <a:gs pos="35000">
+            <a:gs pos="50000">
               <a:schemeClr val="phClr">
-                <a:tint val="37000"/>
-                <a:satMod val="300000"/>
+                <a:lumMod val="105000"/>
+                <a:satMod val="103000"/>
+                <a:tint val="73000"/>
               </a:schemeClr>
             </a:gs>
             <a:gs pos="100000">
               <a:schemeClr val="phClr">
-                <a:tint val="15000"/>
-                <a:satMod val="350000"/>
+                <a:lumMod val="105000"/>
+                <a:satMod val="109000"/>
+                <a:tint val="81000"/>
               </a:schemeClr>
             </a:gs>
           </a:gsLst>
-          <a:lin ang="16200000" scaled="1"/>
+          <a:lin ang="5400000" scaled="0"/>
         </a:gradFill>
         <a:gradFill rotWithShape="1">
           <a:gsLst>
             <a:gs pos="0">
               <a:schemeClr val="phClr">
-                <a:tint val="100000"/>
+                <a:satMod val="103000"/>
+                <a:lumMod val="102000"/>
+                <a:tint val="94000"/>
+              </a:schemeClr>
+            </a:gs>
+            <a:gs pos="50000">
+              <a:schemeClr val="phClr">
+                <a:satMod val="110000"/>
+                <a:lumMod val="100000"/>
                 <a:shade val="100000"/>
-                <a:satMod val="130000"/>
               </a:schemeClr>
             </a:gs>
             <a:gs pos="100000">
               <a:schemeClr val="phClr">
-                <a:tint val="50000"/>
-                <a:shade val="100000"/>
-                <a:satMod val="350000"/>
+                <a:lumMod val="99000"/>
+                <a:satMod val="120000"/>
+                <a:shade val="78000"/>
               </a:schemeClr>
             </a:gs>
           </a:gsLst>
-          <a:lin ang="16200000" scaled="0"/>
+          <a:lin ang="5400000" scaled="0"/>
         </a:gradFill>
       </a:fillStyleLst>
       <a:lnStyleLst>
-        <a:ln w="9525" cap="flat" cmpd="sng" algn="ctr">
+        <a:ln w="12700" cap="flat" cmpd="sng" algn="ctr">
           <a:solidFill>
-            <a:schemeClr val="phClr">
-              <a:shade val="95000"/>
-              <a:satMod val="105000"/>
-            </a:schemeClr>
+            <a:schemeClr val="phClr"/>
           </a:solidFill>
           <a:prstDash val="solid"/>
+          <a:miter lim="800000"/>
+        </a:ln>
+        <a:ln w="19050" cap="flat" cmpd="sng" algn="ctr">
+          <a:solidFill>
+            <a:schemeClr val="phClr"/>
+          </a:solidFill>
+          <a:prstDash val="solid"/>
+          <a:miter lim="800000"/>
         </a:ln>
         <a:ln w="25400" cap="flat" cmpd="sng" algn="ctr">
           <a:solidFill>
             <a:schemeClr val="phClr"/>
           </a:solidFill>
           <a:prstDash val="solid"/>
-        </a:ln>
-        <a:ln w="38100" cap="flat" cmpd="sng" algn="ctr">
-          <a:solidFill>
-            <a:schemeClr val="phClr"/>
-          </a:solidFill>
-          <a:prstDash val="solid"/>
+          <a:miter lim="800000"/>
         </a:ln>
       </a:lnStyleLst>
       <a:effectStyleLst>
         <a:effectStyle>
+          <a:effectLst/>
+        </a:effectStyle>
+        <a:effectStyle>
+          <a:effectLst/>
+        </a:effectStyle>
+        <a:effectStyle>
           <a:effectLst>
-            <a:outerShdw blurRad="40000" dist="20000" dir="5400000" rotWithShape="0">
+            <a:outerShdw blurRad="57150" dist="19050" dir="5400000" algn="ctr" rotWithShape="0">
               <a:srgbClr val="000000">
-                <a:alpha val="38000"/>
+                <a:alpha val="63000"/>
               </a:srgbClr>
             </a:outerShdw>
           </a:effectLst>
-        </a:effectStyle>
-        <a:effectStyle>
-          <a:effectLst>
-            <a:outerShdw blurRad="40000" dist="23000" dir="5400000" rotWithShape="0">
-              <a:srgbClr val="000000">
-                <a:alpha val="35000"/>
-              </a:srgbClr>
-            </a:outerShdw>
-          </a:effectLst>
-        </a:effectStyle>
-        <a:effectStyle>
-          <a:effectLst>
-            <a:outerShdw blurRad="40000" dist="23000" dir="5400000" rotWithShape="0">
-              <a:srgbClr val="000000">
-                <a:alpha val="35000"/>
-              </a:srgbClr>
-            </a:outerShdw>
-          </a:effectLst>
-          <a:scene3d>
-            <a:camera prst="orthographicFront">
-              <a:rot lat="0" lon="0" rev="0"/>
-            </a:camera>
-            <a:lightRig rig="threePt" dir="t">
-              <a:rot lat="0" lon="0" rev="1200000"/>
-            </a:lightRig>
-          </a:scene3d>
-          <a:sp3d>
-            <a:bevelT w="63500" h="25400"/>
-          </a:sp3d>
         </a:effectStyle>
       </a:effectStyleLst>
       <a:bgFillStyleLst>
         <a:solidFill>
           <a:schemeClr val="phClr"/>
         </a:solidFill>
+        <a:solidFill>
+          <a:schemeClr val="phClr">
+            <a:tint val="95000"/>
+            <a:satMod val="170000"/>
+          </a:schemeClr>
+        </a:solidFill>
         <a:gradFill rotWithShape="1">
           <a:gsLst>
             <a:gs pos="0">
               <a:schemeClr val="phClr">
-                <a:tint val="40000"/>
-                <a:satMod val="350000"/>
+                <a:tint val="93000"/>
+                <a:satMod val="150000"/>
+                <a:shade val="98000"/>
+                <a:lumMod val="102000"/>
               </a:schemeClr>
             </a:gs>
-            <a:gs pos="40000">
+            <a:gs pos="50000">
               <a:schemeClr val="phClr">
-                <a:tint val="45000"/>
-                <a:shade val="99000"/>
-                <a:satMod val="350000"/>
+                <a:tint val="98000"/>
+                <a:satMod val="130000"/>
+                <a:shade val="90000"/>
+                <a:lumMod val="103000"/>
               </a:schemeClr>
             </a:gs>
             <a:gs pos="100000">
               <a:schemeClr val="phClr">
-                <a:shade val="20000"/>
-                <a:satMod val="255000"/>
+                <a:shade val="63000"/>
+                <a:satMod val="120000"/>
               </a:schemeClr>
             </a:gs>
           </a:gsLst>
-          <a:path path="circle">
-            <a:fillToRect l="50000" t="-80000" r="50000" b="180000"/>
-          </a:path>
-        </a:gradFill>
-        <a:gradFill rotWithShape="1">
-          <a:gsLst>
-            <a:gs pos="0">
-              <a:schemeClr val="phClr">
-                <a:tint val="80000"/>
-                <a:satMod val="300000"/>
-              </a:schemeClr>
-            </a:gs>
-            <a:gs pos="100000">
-              <a:schemeClr val="phClr">
-                <a:shade val="30000"/>
-                <a:satMod val="200000"/>
-              </a:schemeClr>
-            </a:gs>
-          </a:gsLst>
-          <a:path path="circle">
-            <a:fillToRect l="50000" t="50000" r="50000" b="50000"/>
-          </a:path>
+          <a:lin ang="5400000" scaled="0"/>
         </a:gradFill>
       </a:bgFillStyleLst>
     </a:fmtScheme>
   </a:themeElements>
   <a:objectDefaults>
-    <a:spDef>
-      <a:spPr/>
-      <a:bodyPr/>
-      <a:lstStyle/>
-      <a:style>
-        <a:lnRef idx="1">
-          <a:schemeClr val="accent1"/>
-        </a:lnRef>
-        <a:fillRef idx="3">
-          <a:schemeClr val="accent1"/>
-        </a:fillRef>
-        <a:effectRef idx="2">
-          <a:schemeClr val="accent1"/>
-        </a:effectRef>
-        <a:fontRef idx="minor">
-          <a:schemeClr val="lt1"/>
-        </a:fontRef>
-      </a:style>
-    </a:spDef>
     <a:lnDef>
       <a:spPr/>
       <a:bodyPr/>
@@ -5235,5 +4573,10 @@
     </a:lnDef>
   </a:objectDefaults>
   <a:extraClrSchemeLst/>
+  <a:extLst>
+    <a:ext uri="{05A4C25C-085E-4340-85A3-A5531E510DB2}">
+      <thm15:themeFamily xmlns:thm15="http://schemas.microsoft.com/office/thememl/2012/main" name="Office Theme" id="{2E142A2C-CD16-42D6-873A-C26D2A0506FA}" vid="{1BDDFF52-6CD6-40A5-AB3C-68EB2F1E4D0A}"/>
+    </a:ext>
+  </a:extLst>
 </a:theme>
 </file>
</xml_diff>